<commit_message>
Slide 4 + site: AI install links (Grok Bot, ChatGPT main; Claude, Gemini optional)
</commit_message>
<xml_diff>
--- a/AI_Workshop.pptx
+++ b/AI_Workshop.pptx
@@ -2440,32 +2440,47 @@
           </a:p>
           <a:p>
             <a:r>
-              <a:t>Part 2 วันนี้เราสร้าง Agent บน Grok Bot ซึ่งต้องเตรียมก่อนมา:</a:t>
-            </a:r>
-          </a:p>
-          <a:p>
-            <a:r>
-              <a:t>1) ติดตั้งแอป Grok Bot จาก x.ai/bot (macOS / Windows / Linux) หรือแอปมือถือ iOS (App Store) / Android (Google Play) — docs ระบุ iOS 18+ และ Android 9+ แต่การตั้ง routine แบบแก้ไข/ทดสอบต้องใช้แอปเดสก์ท็อป จึงแนะนำโน้ตบุ๊ก</a:t>
-            </a:r>
-          </a:p>
-          <a:p>
-            <a:r>
-              <a:t>2) Sign in ด้วยบัญชี Cursor ผ่านเบราว์เซอร์ (ปุ่ม Sign in บนเดสก์ท็อป / Log In or Sign Up บนมือถือ)</a:t>
-            </a:r>
-          </a:p>
-          <a:p>
-            <a:r>
-              <a:t>3) ต้องมีสิทธิ์ใช้งาน: Cursor Pro, Pro+, Ultra หรือ Teams — หรือเชื่อม SuperGrok / SuperGrok Plus / SuperGrok Heavy / X Premium+ แบบบุคคล (SuperGrok Lite, Team, Enterprise ใช้ไม่ได้) — ระวัง: การเชื่อม SuperGrok กับบัญชี Cursor ยกเลิก/ย้ายไม่ได้</a:t>
-            </a:r>
-          </a:p>
-          <a:p>
-            <a:r>
-              <a:t>4) ทำขั้นตอนแนะนำครั้งแรกให้จบ (แอปจะตั้งค่าคอมพิวเตอร์บนคลาวด์ในเบื้องหลัง แล้วเปิดหน้า Meet a future teammate)</a:t>
-            </a:r>
-          </a:p>
-          <a:p>
-            <a:r>
-              <a:t>ใครไม่มีแพ็กเกจ: ล็อกอิน ChatGPT ไว้ แล้วทำตามแผนสำรอง ChatGPT Projects (ฟรี)</a:t>
+              <a:t>วันนี้ใช้ 2 แพลตฟอร์มหลัก: Grok Bot (สร้าง Agent ใน Part 2) และ ChatGPT (ตัวอย่างใน Part 1 + แผนสำรองฟรี) — Claude และ Gemini เป็นทางเลือก ใครมีอยู่แล้วลองเทียบได้ ไม่ต้องติดตั้งก็ตามทัน</a:t>
+            </a:r>
+          </a:p>
+          <a:p>
+            <a:r>
+              <a:t>1) ต่อ Wi-Fi ร้าน</a:t>
+            </a:r>
+          </a:p>
+          <a:p>
+            <a:r>
+              <a:t>2) Grok Bot: ติดตั้งจาก x.ai/bot (macOS / Windows / Linux) หรือแอปมือถือ iOS (App Store) / Android (Google Play) — docs ระบุ iOS 18+ และ Android 9+ แต่การตั้ง routine แบบแก้ไข/ทดสอบต้องใช้แอปเดสก์ท็อป จึงแนะนำโน้ตบุ๊ก</a:t>
+            </a:r>
+          </a:p>
+          <a:p>
+            <a:r>
+              <a:t>   - Sign in ด้วยบัญชี Cursor ผ่านเบราว์เซอร์ (ปุ่ม Sign in บนเดสก์ท็อป / Log In or Sign Up บนมือถือ)</a:t>
+            </a:r>
+          </a:p>
+          <a:p>
+            <a:r>
+              <a:t>   - ต้องมีสิทธิ์ใช้งาน: Cursor Pro, Pro+, Ultra หรือ Teams — หรือเชื่อม SuperGrok / SuperGrok Plus / SuperGrok Heavy / X Premium+ แบบบุคคล (SuperGrok Lite, Team, Enterprise ใช้ไม่ได้) — ระวัง: การเชื่อม SuperGrok กับบัญชี Cursor ยกเลิก/ย้ายไม่ได้</a:t>
+            </a:r>
+          </a:p>
+          <a:p>
+            <a:r>
+              <a:t>   - ทำขั้นตอนแนะนำครั้งแรกให้จบ (แอปจะตั้งค่าคอมพิวเตอร์บนคลาวด์ในเบื้องหลัง แล้วเปิดหน้า Meet a future teammate)</a:t>
+            </a:r>
+          </a:p>
+          <a:p>
+            <a:r>
+              <a:t>3) ChatGPT: Sign in ที่ chatgpt.com (บัญชีฟรีพอ) · แอปเดสก์ท็อป/มือถือที่ chatgpt.com/download — ใครไม่มีแพ็กเกจ Grok Bot ให้ทำตามแผนสำรอง ChatGPT Projects</a:t>
+            </a:r>
+          </a:p>
+          <a:p>
+            <a:r>
+              <a:t>4) ทางเลือก: Claude — claude.ai (แอป: claude.ai/download ซึ่ง redirect ไป claude.com/download) · Gemini — gemini.google.com (มือถือ: แอป Gemini ใน App Store / Google Play)</a:t>
+            </a:r>
+          </a:p>
+          <a:p>
+            <a:r>
+              <a:t>ย้ำ: ทำให้เสร็จก่อนวันงาน และใช้บัญชีส่วนตัว ไม่ใช่บัญชีบริษัท</a:t>
             </a:r>
           </a:p>
           <a:p>
@@ -2476,6 +2491,11 @@
           <a:p>
             <a:r>
               <a:t>ราคาแพ็กเกจเป็นบาท — ควรเช็กอีกครั้ง</a:t>
+            </a:r>
+          </a:p>
+          <a:p>
+            <a:r>
+              <a:t>ลิงก์ตรวจแล้ว 3 ต.ค. 2026: x.ai/bot, chatgpt.com, chatgpt.com/download, claude.ai/download, gemini.google.com</a:t>
             </a:r>
           </a:p>
         </p:txBody>
@@ -24684,8 +24704,8 @@
         </p:nvSpPr>
         <p:spPr>
           <a:xfrm>
-            <a:off x="822960" y="1600200"/>
-            <a:ext cx="2514600" cy="3429000"/>
+            <a:off x="822960" y="1572768"/>
+            <a:ext cx="1920240" cy="3520440"/>
           </a:xfrm>
           <a:prstGeom prst="roundRect">
             <a:avLst>
@@ -24728,7 +24748,7 @@
         </p:nvSpPr>
         <p:spPr>
           <a:xfrm>
-            <a:off x="1051560" y="1828800"/>
+            <a:off x="1005840" y="1801368"/>
             <a:ext cx="685800" cy="685800"/>
           </a:xfrm>
           <a:prstGeom prst="ellipse">
@@ -24783,8 +24803,8 @@
         </p:nvSpPr>
         <p:spPr>
           <a:xfrm>
-            <a:off x="1051560" y="2697480"/>
-            <a:ext cx="2103120" cy="548640"/>
+            <a:off x="1005840" y="2670048"/>
+            <a:ext cx="1600200" cy="548640"/>
           </a:xfrm>
           <a:prstGeom prst="rect">
             <a:avLst/>
@@ -24825,8 +24845,8 @@
         </p:nvSpPr>
         <p:spPr>
           <a:xfrm>
-            <a:off x="1051560" y="3246120"/>
-            <a:ext cx="2103120" cy="1737360"/>
+            <a:off x="1005840" y="3218688"/>
+            <a:ext cx="1600200" cy="1737360"/>
           </a:xfrm>
           <a:prstGeom prst="rect">
             <a:avLst/>
@@ -24867,8 +24887,749 @@
         </p:nvSpPr>
         <p:spPr>
           <a:xfrm>
-            <a:off x="3520440" y="1600200"/>
-            <a:ext cx="2514600" cy="3429000"/>
+            <a:off x="2926080" y="1572768"/>
+            <a:ext cx="2743200" cy="3520440"/>
+          </a:xfrm>
+          <a:prstGeom prst="roundRect">
+            <a:avLst>
+              <a:gd name="adj" fmla="val 8000"/>
+            </a:avLst>
+          </a:prstGeom>
+          <a:solidFill>
+            <a:srgbClr val="FFFFFF"/>
+          </a:solidFill>
+          <a:ln w="15875">
+            <a:solidFill>
+              <a:srgbClr val="7B4FC9"/>
+            </a:solidFill>
+          </a:ln>
+          <a:effectLst/>
+        </p:spPr>
+        <p:style>
+          <a:lnRef idx="1">
+            <a:schemeClr val="accent1"/>
+          </a:lnRef>
+          <a:fillRef idx="3">
+            <a:schemeClr val="accent1"/>
+          </a:fillRef>
+          <a:effectRef idx="2">
+            <a:schemeClr val="accent1"/>
+          </a:effectRef>
+          <a:fontRef idx="minor">
+            <a:schemeClr val="lt1"/>
+          </a:fontRef>
+        </p:style>
+        <p:txBody>
+          <a:bodyPr rtlCol="0" anchor="ctr"/>
+          <a:lstStyle/>
+          <a:p/>
+        </p:txBody>
+      </p:sp>
+      <p:sp>
+        <p:nvSpPr>
+          <p:cNvPr id="13" name="Rounded Rectangle 12"/>
+          <p:cNvSpPr/>
+          <p:nvPr/>
+        </p:nvSpPr>
+        <p:spPr>
+          <a:xfrm>
+            <a:off x="3154680" y="1801368"/>
+            <a:ext cx="1920240" cy="347472"/>
+          </a:xfrm>
+          <a:prstGeom prst="roundRect">
+            <a:avLst>
+              <a:gd name="adj" fmla="val 50000"/>
+            </a:avLst>
+          </a:prstGeom>
+          <a:solidFill>
+            <a:srgbClr val="4B2A7B"/>
+          </a:solidFill>
+          <a:ln>
+            <a:noFill/>
+          </a:ln>
+          <a:effectLst/>
+        </p:spPr>
+        <p:style>
+          <a:lnRef idx="1">
+            <a:schemeClr val="accent1"/>
+          </a:lnRef>
+          <a:fillRef idx="3">
+            <a:schemeClr val="accent1"/>
+          </a:fillRef>
+          <a:effectRef idx="2">
+            <a:schemeClr val="accent1"/>
+          </a:effectRef>
+          <a:fontRef idx="minor">
+            <a:schemeClr val="lt1"/>
+          </a:fontRef>
+        </p:style>
+        <p:txBody>
+          <a:bodyPr rtlCol="0" anchor="ctr" wrap="square" lIns="27432" rIns="27432" tIns="27432" bIns="27432"/>
+          <a:lstStyle/>
+          <a:p>
+            <a:pPr algn="ctr"/>
+            <a:r>
+              <a:rPr sz="1200" b="1">
+                <a:solidFill>
+                  <a:srgbClr val="FFFFFF"/>
+                </a:solidFill>
+                <a:latin typeface="Prompt"/>
+                <a:ea typeface="Prompt"/>
+                <a:cs typeface="Prompt"/>
+              </a:rPr>
+              <a:t>★ ใช้หลักใน Workshop</a:t>
+            </a:r>
+          </a:p>
+        </p:txBody>
+      </p:sp>
+      <p:sp>
+        <p:nvSpPr>
+          <p:cNvPr id="14" name="Oval 13"/>
+          <p:cNvSpPr/>
+          <p:nvPr/>
+        </p:nvSpPr>
+        <p:spPr>
+          <a:xfrm>
+            <a:off x="5120640" y="1755648"/>
+            <a:ext cx="438912" cy="438912"/>
+          </a:xfrm>
+          <a:prstGeom prst="ellipse">
+            <a:avLst/>
+          </a:prstGeom>
+          <a:solidFill>
+            <a:srgbClr val="7B4FC9"/>
+          </a:solidFill>
+          <a:ln>
+            <a:noFill/>
+          </a:ln>
+          <a:effectLst/>
+        </p:spPr>
+        <p:style>
+          <a:lnRef idx="1">
+            <a:schemeClr val="accent1"/>
+          </a:lnRef>
+          <a:fillRef idx="3">
+            <a:schemeClr val="accent1"/>
+          </a:fillRef>
+          <a:effectRef idx="2">
+            <a:schemeClr val="accent1"/>
+          </a:effectRef>
+          <a:fontRef idx="minor">
+            <a:schemeClr val="lt1"/>
+          </a:fontRef>
+        </p:style>
+        <p:txBody>
+          <a:bodyPr rtlCol="0" anchor="ctr" wrap="square" lIns="0" rIns="0" tIns="0" bIns="0"/>
+          <a:lstStyle/>
+          <a:p>
+            <a:pPr algn="ctr"/>
+            <a:r>
+              <a:rPr sz="1500" b="1">
+                <a:solidFill>
+                  <a:srgbClr val="FFFFFF"/>
+                </a:solidFill>
+                <a:latin typeface="Prompt"/>
+                <a:ea typeface="Prompt"/>
+                <a:cs typeface="Prompt"/>
+              </a:rPr>
+              <a:t>2</a:t>
+            </a:r>
+          </a:p>
+        </p:txBody>
+      </p:sp>
+      <p:sp>
+        <p:nvSpPr>
+          <p:cNvPr id="15" name="TextBox 14"/>
+          <p:cNvSpPr txBox="1"/>
+          <p:nvPr/>
+        </p:nvSpPr>
+        <p:spPr>
+          <a:xfrm>
+            <a:off x="3154680" y="2286000"/>
+            <a:ext cx="2377440" cy="457200"/>
+          </a:xfrm>
+          <a:prstGeom prst="rect">
+            <a:avLst/>
+          </a:prstGeom>
+          <a:noFill/>
+        </p:spPr>
+        <p:txBody>
+          <a:bodyPr wrap="square" anchor="t" lIns="45720" rIns="45720"/>
+          <a:lstStyle/>
+          <a:p>
+            <a:pPr algn="l">
+              <a:lnSpc>
+                <a:spcPct val="110000"/>
+              </a:lnSpc>
+              <a:spcAft>
+                <a:spcPts val="400"/>
+              </a:spcAft>
+            </a:pPr>
+            <a:r>
+              <a:rPr sz="2200" b="1" i="0">
+                <a:solidFill>
+                  <a:srgbClr val="4B2A7B"/>
+                </a:solidFill>
+                <a:latin typeface="Prompt"/>
+                <a:ea typeface="Prompt"/>
+                <a:cs typeface="Prompt"/>
+              </a:rPr>
+              <a:t>Grok Bot</a:t>
+            </a:r>
+          </a:p>
+        </p:txBody>
+      </p:sp>
+      <p:sp>
+        <p:nvSpPr>
+          <p:cNvPr id="16" name="TextBox 15"/>
+          <p:cNvSpPr txBox="1"/>
+          <p:nvPr/>
+        </p:nvSpPr>
+        <p:spPr>
+          <a:xfrm>
+            <a:off x="3154680" y="2743200"/>
+            <a:ext cx="2377440" cy="320040"/>
+          </a:xfrm>
+          <a:prstGeom prst="rect">
+            <a:avLst/>
+          </a:prstGeom>
+          <a:noFill/>
+        </p:spPr>
+        <p:txBody>
+          <a:bodyPr wrap="square" anchor="t" lIns="45720" rIns="45720"/>
+          <a:lstStyle/>
+          <a:p>
+            <a:pPr algn="l">
+              <a:lnSpc>
+                <a:spcPct val="110000"/>
+              </a:lnSpc>
+              <a:spcAft>
+                <a:spcPts val="400"/>
+              </a:spcAft>
+            </a:pPr>
+            <a:r>
+              <a:rPr sz="1350" b="1" i="0">
+                <a:solidFill>
+                  <a:srgbClr val="7B4FC9"/>
+                </a:solidFill>
+                <a:latin typeface="Prompt"/>
+                <a:ea typeface="Prompt"/>
+                <a:cs typeface="Prompt"/>
+              </a:rPr>
+              <a:t>สร้าง Agent ใน Part 2</a:t>
+            </a:r>
+          </a:p>
+        </p:txBody>
+      </p:sp>
+      <p:sp>
+        <p:nvSpPr>
+          <p:cNvPr id="17" name="TextBox 16"/>
+          <p:cNvSpPr txBox="1"/>
+          <p:nvPr/>
+        </p:nvSpPr>
+        <p:spPr>
+          <a:xfrm>
+            <a:off x="3108960" y="3127248"/>
+            <a:ext cx="2468880" cy="1874519"/>
+          </a:xfrm>
+          <a:prstGeom prst="rect">
+            <a:avLst/>
+          </a:prstGeom>
+          <a:noFill/>
+        </p:spPr>
+        <p:txBody>
+          <a:bodyPr wrap="square" anchor="t" lIns="45720" rIns="45720"/>
+          <a:lstStyle/>
+          <a:p>
+            <a:pPr algn="l">
+              <a:lnSpc>
+                <a:spcPct val="105000"/>
+              </a:lnSpc>
+              <a:spcAft>
+                <a:spcPts val="500"/>
+              </a:spcAft>
+            </a:pPr>
+            <a:r>
+              <a:rPr sz="1400" b="1" i="0">
+                <a:solidFill>
+                  <a:srgbClr val="2E2A36"/>
+                </a:solidFill>
+                <a:latin typeface="Sarabun"/>
+                <a:ea typeface="Sarabun"/>
+                <a:cs typeface="Sarabun"/>
+              </a:rPr>
+              <a:t>ติดตั้ง: </a:t>
+            </a:r>
+            <a:r>
+              <a:rPr sz="1400" b="1" i="0" u="sng">
+                <a:solidFill>
+                  <a:srgbClr val="7B4FC9"/>
+                </a:solidFill>
+                <a:latin typeface="Sarabun"/>
+                <a:ea typeface="Sarabun"/>
+                <a:cs typeface="Sarabun"/>
+                <a:hlinkClick r:id="rId2"/>
+              </a:rPr>
+              <a:t>x.ai/bot</a:t>
+            </a:r>
+          </a:p>
+          <a:p>
+            <a:pPr algn="l">
+              <a:lnSpc>
+                <a:spcPct val="105000"/>
+              </a:lnSpc>
+              <a:spcAft>
+                <a:spcPts val="500"/>
+              </a:spcAft>
+            </a:pPr>
+            <a:r>
+              <a:rPr sz="1400" b="1" i="0">
+                <a:solidFill>
+                  <a:srgbClr val="2E2A36"/>
+                </a:solidFill>
+                <a:latin typeface="Sarabun"/>
+                <a:ea typeface="Sarabun"/>
+                <a:cs typeface="Sarabun"/>
+              </a:rPr>
+              <a:t>Sign in: </a:t>
+            </a:r>
+            <a:r>
+              <a:rPr sz="1400" b="0" i="0">
+                <a:solidFill>
+                  <a:srgbClr val="2E2A36"/>
+                </a:solidFill>
+                <a:latin typeface="Sarabun"/>
+                <a:ea typeface="Sarabun"/>
+                <a:cs typeface="Sarabun"/>
+              </a:rPr>
+              <a:t>บัญชี Cursor</a:t>
+            </a:r>
+          </a:p>
+          <a:p>
+            <a:pPr algn="l">
+              <a:lnSpc>
+                <a:spcPct val="105000"/>
+              </a:lnSpc>
+              <a:spcAft>
+                <a:spcPts val="500"/>
+              </a:spcAft>
+            </a:pPr>
+            <a:r>
+              <a:rPr sz="1250" b="0" i="0">
+                <a:solidFill>
+                  <a:srgbClr val="5F596B"/>
+                </a:solidFill>
+                <a:latin typeface="Sarabun"/>
+                <a:ea typeface="Sarabun"/>
+                <a:cs typeface="Sarabun"/>
+              </a:rPr>
+              <a:t>Mac / Windows / Linux / มือถือ · แนะนำโน้ตบุ๊ก</a:t>
+            </a:r>
+          </a:p>
+          <a:p>
+            <a:pPr algn="l">
+              <a:lnSpc>
+                <a:spcPct val="105000"/>
+              </a:lnSpc>
+              <a:spcAft>
+                <a:spcPts val="500"/>
+              </a:spcAft>
+            </a:pPr>
+            <a:r>
+              <a:rPr sz="1250" b="0" i="0">
+                <a:solidFill>
+                  <a:srgbClr val="5F596B"/>
+                </a:solidFill>
+                <a:latin typeface="Sarabun"/>
+                <a:ea typeface="Sarabun"/>
+                <a:cs typeface="Sarabun"/>
+              </a:rPr>
+              <a:t>ต้องมี Cursor Pro / Pro+ / Ultra / Teams หรือ SuperGrok / X Premium+</a:t>
+            </a:r>
+          </a:p>
+        </p:txBody>
+      </p:sp>
+      <p:sp>
+        <p:nvSpPr>
+          <p:cNvPr id="18" name="Rounded Rectangle 17"/>
+          <p:cNvSpPr/>
+          <p:nvPr/>
+        </p:nvSpPr>
+        <p:spPr>
+          <a:xfrm>
+            <a:off x="5852160" y="1572768"/>
+            <a:ext cx="2743200" cy="3520440"/>
+          </a:xfrm>
+          <a:prstGeom prst="roundRect">
+            <a:avLst>
+              <a:gd name="adj" fmla="val 8000"/>
+            </a:avLst>
+          </a:prstGeom>
+          <a:solidFill>
+            <a:srgbClr val="FFFFFF"/>
+          </a:solidFill>
+          <a:ln w="15875">
+            <a:solidFill>
+              <a:srgbClr val="7B4FC9"/>
+            </a:solidFill>
+          </a:ln>
+          <a:effectLst/>
+        </p:spPr>
+        <p:style>
+          <a:lnRef idx="1">
+            <a:schemeClr val="accent1"/>
+          </a:lnRef>
+          <a:fillRef idx="3">
+            <a:schemeClr val="accent1"/>
+          </a:fillRef>
+          <a:effectRef idx="2">
+            <a:schemeClr val="accent1"/>
+          </a:effectRef>
+          <a:fontRef idx="minor">
+            <a:schemeClr val="lt1"/>
+          </a:fontRef>
+        </p:style>
+        <p:txBody>
+          <a:bodyPr rtlCol="0" anchor="ctr"/>
+          <a:lstStyle/>
+          <a:p/>
+        </p:txBody>
+      </p:sp>
+      <p:sp>
+        <p:nvSpPr>
+          <p:cNvPr id="19" name="Rounded Rectangle 18"/>
+          <p:cNvSpPr/>
+          <p:nvPr/>
+        </p:nvSpPr>
+        <p:spPr>
+          <a:xfrm>
+            <a:off x="6080760" y="1801368"/>
+            <a:ext cx="1920240" cy="347472"/>
+          </a:xfrm>
+          <a:prstGeom prst="roundRect">
+            <a:avLst>
+              <a:gd name="adj" fmla="val 50000"/>
+            </a:avLst>
+          </a:prstGeom>
+          <a:solidFill>
+            <a:srgbClr val="4B2A7B"/>
+          </a:solidFill>
+          <a:ln>
+            <a:noFill/>
+          </a:ln>
+          <a:effectLst/>
+        </p:spPr>
+        <p:style>
+          <a:lnRef idx="1">
+            <a:schemeClr val="accent1"/>
+          </a:lnRef>
+          <a:fillRef idx="3">
+            <a:schemeClr val="accent1"/>
+          </a:fillRef>
+          <a:effectRef idx="2">
+            <a:schemeClr val="accent1"/>
+          </a:effectRef>
+          <a:fontRef idx="minor">
+            <a:schemeClr val="lt1"/>
+          </a:fontRef>
+        </p:style>
+        <p:txBody>
+          <a:bodyPr rtlCol="0" anchor="ctr" wrap="square" lIns="27432" rIns="27432" tIns="27432" bIns="27432"/>
+          <a:lstStyle/>
+          <a:p>
+            <a:pPr algn="ctr"/>
+            <a:r>
+              <a:rPr sz="1200" b="1">
+                <a:solidFill>
+                  <a:srgbClr val="FFFFFF"/>
+                </a:solidFill>
+                <a:latin typeface="Prompt"/>
+                <a:ea typeface="Prompt"/>
+                <a:cs typeface="Prompt"/>
+              </a:rPr>
+              <a:t>★ ใช้หลักใน Workshop</a:t>
+            </a:r>
+          </a:p>
+        </p:txBody>
+      </p:sp>
+      <p:sp>
+        <p:nvSpPr>
+          <p:cNvPr id="20" name="Oval 19"/>
+          <p:cNvSpPr/>
+          <p:nvPr/>
+        </p:nvSpPr>
+        <p:spPr>
+          <a:xfrm>
+            <a:off x="8046720" y="1755648"/>
+            <a:ext cx="438912" cy="438912"/>
+          </a:xfrm>
+          <a:prstGeom prst="ellipse">
+            <a:avLst/>
+          </a:prstGeom>
+          <a:solidFill>
+            <a:srgbClr val="7B4FC9"/>
+          </a:solidFill>
+          <a:ln>
+            <a:noFill/>
+          </a:ln>
+          <a:effectLst/>
+        </p:spPr>
+        <p:style>
+          <a:lnRef idx="1">
+            <a:schemeClr val="accent1"/>
+          </a:lnRef>
+          <a:fillRef idx="3">
+            <a:schemeClr val="accent1"/>
+          </a:fillRef>
+          <a:effectRef idx="2">
+            <a:schemeClr val="accent1"/>
+          </a:effectRef>
+          <a:fontRef idx="minor">
+            <a:schemeClr val="lt1"/>
+          </a:fontRef>
+        </p:style>
+        <p:txBody>
+          <a:bodyPr rtlCol="0" anchor="ctr" wrap="square" lIns="0" rIns="0" tIns="0" bIns="0"/>
+          <a:lstStyle/>
+          <a:p>
+            <a:pPr algn="ctr"/>
+            <a:r>
+              <a:rPr sz="1500" b="1">
+                <a:solidFill>
+                  <a:srgbClr val="FFFFFF"/>
+                </a:solidFill>
+                <a:latin typeface="Prompt"/>
+                <a:ea typeface="Prompt"/>
+                <a:cs typeface="Prompt"/>
+              </a:rPr>
+              <a:t>3</a:t>
+            </a:r>
+          </a:p>
+        </p:txBody>
+      </p:sp>
+      <p:sp>
+        <p:nvSpPr>
+          <p:cNvPr id="21" name="TextBox 20"/>
+          <p:cNvSpPr txBox="1"/>
+          <p:nvPr/>
+        </p:nvSpPr>
+        <p:spPr>
+          <a:xfrm>
+            <a:off x="6080760" y="2286000"/>
+            <a:ext cx="2377440" cy="457200"/>
+          </a:xfrm>
+          <a:prstGeom prst="rect">
+            <a:avLst/>
+          </a:prstGeom>
+          <a:noFill/>
+        </p:spPr>
+        <p:txBody>
+          <a:bodyPr wrap="square" anchor="t" lIns="45720" rIns="45720"/>
+          <a:lstStyle/>
+          <a:p>
+            <a:pPr algn="l">
+              <a:lnSpc>
+                <a:spcPct val="110000"/>
+              </a:lnSpc>
+              <a:spcAft>
+                <a:spcPts val="400"/>
+              </a:spcAft>
+            </a:pPr>
+            <a:r>
+              <a:rPr sz="2200" b="1" i="0">
+                <a:solidFill>
+                  <a:srgbClr val="4B2A7B"/>
+                </a:solidFill>
+                <a:latin typeface="Prompt"/>
+                <a:ea typeface="Prompt"/>
+                <a:cs typeface="Prompt"/>
+              </a:rPr>
+              <a:t>ChatGPT</a:t>
+            </a:r>
+          </a:p>
+        </p:txBody>
+      </p:sp>
+      <p:sp>
+        <p:nvSpPr>
+          <p:cNvPr id="22" name="TextBox 21"/>
+          <p:cNvSpPr txBox="1"/>
+          <p:nvPr/>
+        </p:nvSpPr>
+        <p:spPr>
+          <a:xfrm>
+            <a:off x="6080760" y="2743200"/>
+            <a:ext cx="2377440" cy="320040"/>
+          </a:xfrm>
+          <a:prstGeom prst="rect">
+            <a:avLst/>
+          </a:prstGeom>
+          <a:noFill/>
+        </p:spPr>
+        <p:txBody>
+          <a:bodyPr wrap="square" anchor="t" lIns="45720" rIns="45720"/>
+          <a:lstStyle/>
+          <a:p>
+            <a:pPr algn="l">
+              <a:lnSpc>
+                <a:spcPct val="110000"/>
+              </a:lnSpc>
+              <a:spcAft>
+                <a:spcPts val="400"/>
+              </a:spcAft>
+            </a:pPr>
+            <a:r>
+              <a:rPr sz="1350" b="1" i="0">
+                <a:solidFill>
+                  <a:srgbClr val="7B4FC9"/>
+                </a:solidFill>
+                <a:latin typeface="Prompt"/>
+                <a:ea typeface="Prompt"/>
+                <a:cs typeface="Prompt"/>
+              </a:rPr>
+              <a:t>Part 1 + แผนสำรอง (ฟรี)</a:t>
+            </a:r>
+          </a:p>
+        </p:txBody>
+      </p:sp>
+      <p:sp>
+        <p:nvSpPr>
+          <p:cNvPr id="23" name="TextBox 22"/>
+          <p:cNvSpPr txBox="1"/>
+          <p:nvPr/>
+        </p:nvSpPr>
+        <p:spPr>
+          <a:xfrm>
+            <a:off x="6035040" y="3127248"/>
+            <a:ext cx="2468880" cy="1874519"/>
+          </a:xfrm>
+          <a:prstGeom prst="rect">
+            <a:avLst/>
+          </a:prstGeom>
+          <a:noFill/>
+        </p:spPr>
+        <p:txBody>
+          <a:bodyPr wrap="square" anchor="t" lIns="45720" rIns="45720"/>
+          <a:lstStyle/>
+          <a:p>
+            <a:pPr algn="l">
+              <a:lnSpc>
+                <a:spcPct val="105000"/>
+              </a:lnSpc>
+              <a:spcAft>
+                <a:spcPts val="500"/>
+              </a:spcAft>
+            </a:pPr>
+            <a:r>
+              <a:rPr sz="1400" b="1" i="0">
+                <a:solidFill>
+                  <a:srgbClr val="2E2A36"/>
+                </a:solidFill>
+                <a:latin typeface="Sarabun"/>
+                <a:ea typeface="Sarabun"/>
+                <a:cs typeface="Sarabun"/>
+              </a:rPr>
+              <a:t>Sign in: </a:t>
+            </a:r>
+            <a:r>
+              <a:rPr sz="1400" b="1" i="0" u="sng">
+                <a:solidFill>
+                  <a:srgbClr val="7B4FC9"/>
+                </a:solidFill>
+                <a:latin typeface="Sarabun"/>
+                <a:ea typeface="Sarabun"/>
+                <a:cs typeface="Sarabun"/>
+                <a:hlinkClick r:id="rId3"/>
+              </a:rPr>
+              <a:t>chatgpt.com</a:t>
+            </a:r>
+          </a:p>
+          <a:p>
+            <a:pPr algn="l">
+              <a:lnSpc>
+                <a:spcPct val="105000"/>
+              </a:lnSpc>
+              <a:spcAft>
+                <a:spcPts val="500"/>
+              </a:spcAft>
+            </a:pPr>
+            <a:r>
+              <a:rPr sz="1350" b="1" i="0">
+                <a:solidFill>
+                  <a:srgbClr val="2E2A36"/>
+                </a:solidFill>
+                <a:latin typeface="Sarabun"/>
+                <a:ea typeface="Sarabun"/>
+                <a:cs typeface="Sarabun"/>
+              </a:rPr>
+              <a:t>แอป: </a:t>
+            </a:r>
+            <a:r>
+              <a:rPr sz="1350" b="1" i="0" u="sng">
+                <a:solidFill>
+                  <a:srgbClr val="7B4FC9"/>
+                </a:solidFill>
+                <a:latin typeface="Sarabun"/>
+                <a:ea typeface="Sarabun"/>
+                <a:cs typeface="Sarabun"/>
+                <a:hlinkClick r:id="rId4"/>
+              </a:rPr>
+              <a:t>chatgpt.com/download</a:t>
+            </a:r>
+          </a:p>
+          <a:p>
+            <a:pPr algn="l">
+              <a:lnSpc>
+                <a:spcPct val="105000"/>
+              </a:lnSpc>
+              <a:spcAft>
+                <a:spcPts val="500"/>
+              </a:spcAft>
+            </a:pPr>
+            <a:r>
+              <a:rPr sz="1250" b="0" i="0">
+                <a:solidFill>
+                  <a:srgbClr val="5F596B"/>
+                </a:solidFill>
+                <a:latin typeface="Sarabun"/>
+                <a:ea typeface="Sarabun"/>
+                <a:cs typeface="Sarabun"/>
+              </a:rPr>
+              <a:t>บัญชีฟรีใช้ได้</a:t>
+            </a:r>
+          </a:p>
+          <a:p>
+            <a:pPr algn="l">
+              <a:lnSpc>
+                <a:spcPct val="105000"/>
+              </a:lnSpc>
+              <a:spcAft>
+                <a:spcPts val="500"/>
+              </a:spcAft>
+            </a:pPr>
+            <a:r>
+              <a:rPr sz="1250" b="0" i="0">
+                <a:solidFill>
+                  <a:srgbClr val="5F596B"/>
+                </a:solidFill>
+                <a:latin typeface="Sarabun"/>
+                <a:ea typeface="Sarabun"/>
+                <a:cs typeface="Sarabun"/>
+              </a:rPr>
+              <a:t>ไม่มีแพ็กเกจ Grok Bot? ใช้ ChatGPT Projects ฟรีแทนได้</a:t>
+            </a:r>
+          </a:p>
+        </p:txBody>
+      </p:sp>
+      <p:sp>
+        <p:nvSpPr>
+          <p:cNvPr id="24" name="Rounded Rectangle 23"/>
+          <p:cNvSpPr/>
+          <p:nvPr/>
+        </p:nvSpPr>
+        <p:spPr>
+          <a:xfrm>
+            <a:off x="8778240" y="1572768"/>
+            <a:ext cx="2560320" cy="3520440"/>
           </a:xfrm>
           <a:prstGeom prst="roundRect">
             <a:avLst>
@@ -24905,20 +25666,22 @@
       </p:sp>
       <p:sp>
         <p:nvSpPr>
-          <p:cNvPr id="13" name="Oval 12"/>
+          <p:cNvPr id="25" name="Rounded Rectangle 24"/>
           <p:cNvSpPr/>
           <p:nvPr/>
         </p:nvSpPr>
         <p:spPr>
           <a:xfrm>
-            <a:off x="3749039" y="1828800"/>
-            <a:ext cx="685800" cy="685800"/>
-          </a:xfrm>
-          <a:prstGeom prst="ellipse">
-            <a:avLst/>
+            <a:off x="9006840" y="1801368"/>
+            <a:ext cx="1051560" cy="347472"/>
+          </a:xfrm>
+          <a:prstGeom prst="roundRect">
+            <a:avLst>
+              <a:gd name="adj" fmla="val 50000"/>
+            </a:avLst>
           </a:prstGeom>
           <a:solidFill>
-            <a:srgbClr val="7B4FC9"/>
+            <a:srgbClr val="E7DEF8"/>
           </a:solidFill>
           <a:ln>
             <a:noFill/>
@@ -24940,34 +25703,34 @@
           </a:fontRef>
         </p:style>
         <p:txBody>
-          <a:bodyPr rtlCol="0" anchor="ctr" wrap="square" lIns="73152" rIns="73152" tIns="73152" bIns="73152"/>
+          <a:bodyPr rtlCol="0" anchor="ctr" wrap="square" lIns="27432" rIns="27432" tIns="27432" bIns="27432"/>
           <a:lstStyle/>
           <a:p>
             <a:pPr algn="ctr"/>
             <a:r>
-              <a:rPr sz="2200" b="1">
-                <a:solidFill>
-                  <a:srgbClr val="FFFFFF"/>
+              <a:rPr sz="1200" b="1">
+                <a:solidFill>
+                  <a:srgbClr val="4B2A7B"/>
                 </a:solidFill>
                 <a:latin typeface="Prompt"/>
                 <a:ea typeface="Prompt"/>
                 <a:cs typeface="Prompt"/>
               </a:rPr>
-              <a:t>2</a:t>
-            </a:r>
-          </a:p>
-        </p:txBody>
-      </p:sp>
-      <p:sp>
-        <p:nvSpPr>
-          <p:cNvPr id="14" name="TextBox 13"/>
+              <a:t>ทางเลือก</a:t>
+            </a:r>
+          </a:p>
+        </p:txBody>
+      </p:sp>
+      <p:sp>
+        <p:nvSpPr>
+          <p:cNvPr id="26" name="TextBox 25"/>
           <p:cNvSpPr txBox="1"/>
           <p:nvPr/>
         </p:nvSpPr>
         <p:spPr>
           <a:xfrm>
-            <a:off x="3749039" y="2697480"/>
-            <a:ext cx="2103120" cy="548640"/>
+            <a:off x="9006840" y="2286000"/>
+            <a:ext cx="2194560" cy="457200"/>
           </a:xfrm>
           <a:prstGeom prst="rect">
             <a:avLst/>
@@ -24987,7 +25750,7 @@
               </a:spcAft>
             </a:pPr>
             <a:r>
-              <a:rPr sz="1900" b="1" i="0">
+              <a:rPr sz="1800" b="1" i="0">
                 <a:solidFill>
                   <a:srgbClr val="4B2A7B"/>
                 </a:solidFill>
@@ -24995,21 +25758,21 @@
                 <a:ea typeface="Prompt"/>
                 <a:cs typeface="Prompt"/>
               </a:rPr>
-              <a:t>ติดตั้ง Grok Bot</a:t>
-            </a:r>
-          </a:p>
-        </p:txBody>
-      </p:sp>
-      <p:sp>
-        <p:nvSpPr>
-          <p:cNvPr id="15" name="TextBox 14"/>
+              <a:t>ลองเพิ่มได้</a:t>
+            </a:r>
+          </a:p>
+        </p:txBody>
+      </p:sp>
+      <p:sp>
+        <p:nvSpPr>
+          <p:cNvPr id="27" name="TextBox 26"/>
           <p:cNvSpPr txBox="1"/>
           <p:nvPr/>
         </p:nvSpPr>
         <p:spPr>
           <a:xfrm>
-            <a:off x="3749039" y="3246120"/>
-            <a:ext cx="2103120" cy="1737360"/>
+            <a:off x="9006840" y="2761488"/>
+            <a:ext cx="2240280" cy="2240280"/>
           </a:xfrm>
           <a:prstGeom prst="rect">
             <a:avLst/>
@@ -25022,401 +25785,154 @@
           <a:p>
             <a:pPr algn="l">
               <a:lnSpc>
-                <a:spcPct val="110000"/>
-              </a:lnSpc>
-              <a:spcAft>
-                <a:spcPts val="400"/>
-              </a:spcAft>
-            </a:pPr>
-            <a:r>
-              <a:rPr sz="1500" b="0" i="0">
-                <a:solidFill>
-                  <a:srgbClr val="2E2A36"/>
+                <a:spcPct val="100000"/>
+              </a:lnSpc>
+              <a:spcAft>
+                <a:spcPts val="300"/>
+              </a:spcAft>
+            </a:pPr>
+            <a:r>
+              <a:rPr sz="1500" b="1" i="0">
+                <a:solidFill>
+                  <a:srgbClr val="4B2A7B"/>
+                </a:solidFill>
+                <a:latin typeface="Prompt"/>
+                <a:ea typeface="Prompt"/>
+                <a:cs typeface="Prompt"/>
+              </a:rPr>
+              <a:t>Claude</a:t>
+            </a:r>
+          </a:p>
+          <a:p>
+            <a:pPr algn="l">
+              <a:lnSpc>
+                <a:spcPct val="100000"/>
+              </a:lnSpc>
+              <a:spcAft>
+                <a:spcPts val="300"/>
+              </a:spcAft>
+            </a:pPr>
+            <a:r>
+              <a:rPr sz="1350" b="1" i="0" u="sng">
+                <a:solidFill>
+                  <a:srgbClr val="7B4FC9"/>
                 </a:solidFill>
                 <a:latin typeface="Sarabun"/>
                 <a:ea typeface="Sarabun"/>
                 <a:cs typeface="Sarabun"/>
-              </a:rPr>
-              <a:t>x.ai/bot · Mac / Windows / Linux หรือแอป iOS / Android · แนะนำโน้ตบุ๊ก</a:t>
-            </a:r>
-          </a:p>
-        </p:txBody>
-      </p:sp>
-      <p:sp>
-        <p:nvSpPr>
-          <p:cNvPr id="16" name="Rounded Rectangle 15"/>
-          <p:cNvSpPr/>
-          <p:nvPr/>
-        </p:nvSpPr>
-        <p:spPr>
-          <a:xfrm>
-            <a:off x="6217920" y="1600200"/>
-            <a:ext cx="2514600" cy="3429000"/>
-          </a:xfrm>
-          <a:prstGeom prst="roundRect">
-            <a:avLst>
-              <a:gd name="adj" fmla="val 8000"/>
-            </a:avLst>
-          </a:prstGeom>
-          <a:solidFill>
-            <a:srgbClr val="FFFFFF"/>
-          </a:solidFill>
-          <a:ln>
-            <a:noFill/>
-          </a:ln>
-          <a:effectLst/>
-        </p:spPr>
-        <p:style>
-          <a:lnRef idx="1">
-            <a:schemeClr val="accent1"/>
-          </a:lnRef>
-          <a:fillRef idx="3">
-            <a:schemeClr val="accent1"/>
-          </a:fillRef>
-          <a:effectRef idx="2">
-            <a:schemeClr val="accent1"/>
-          </a:effectRef>
-          <a:fontRef idx="minor">
-            <a:schemeClr val="lt1"/>
-          </a:fontRef>
-        </p:style>
-        <p:txBody>
-          <a:bodyPr rtlCol="0" anchor="ctr"/>
-          <a:lstStyle/>
-          <a:p/>
-        </p:txBody>
-      </p:sp>
-      <p:sp>
-        <p:nvSpPr>
-          <p:cNvPr id="17" name="Oval 16"/>
-          <p:cNvSpPr/>
-          <p:nvPr/>
-        </p:nvSpPr>
-        <p:spPr>
-          <a:xfrm>
-            <a:off x="6446520" y="1828800"/>
-            <a:ext cx="685800" cy="685800"/>
-          </a:xfrm>
-          <a:prstGeom prst="ellipse">
-            <a:avLst/>
-          </a:prstGeom>
-          <a:solidFill>
-            <a:srgbClr val="7B4FC9"/>
-          </a:solidFill>
-          <a:ln>
-            <a:noFill/>
-          </a:ln>
-          <a:effectLst/>
-        </p:spPr>
-        <p:style>
-          <a:lnRef idx="1">
-            <a:schemeClr val="accent1"/>
-          </a:lnRef>
-          <a:fillRef idx="3">
-            <a:schemeClr val="accent1"/>
-          </a:fillRef>
-          <a:effectRef idx="2">
-            <a:schemeClr val="accent1"/>
-          </a:effectRef>
-          <a:fontRef idx="minor">
-            <a:schemeClr val="lt1"/>
-          </a:fontRef>
-        </p:style>
-        <p:txBody>
-          <a:bodyPr rtlCol="0" anchor="ctr" wrap="square" lIns="73152" rIns="73152" tIns="73152" bIns="73152"/>
-          <a:lstStyle/>
-          <a:p>
-            <a:pPr algn="ctr"/>
-            <a:r>
-              <a:rPr sz="2200" b="1">
-                <a:solidFill>
-                  <a:srgbClr val="FFFFFF"/>
+                <a:hlinkClick r:id="rId5"/>
+              </a:rPr>
+              <a:t>claude.ai</a:t>
+            </a:r>
+          </a:p>
+          <a:p>
+            <a:pPr algn="l">
+              <a:lnSpc>
+                <a:spcPct val="100000"/>
+              </a:lnSpc>
+              <a:spcAft>
+                <a:spcPts val="300"/>
+              </a:spcAft>
+            </a:pPr>
+            <a:r>
+              <a:rPr sz="1350" b="1" i="0">
+                <a:solidFill>
+                  <a:srgbClr val="2E2A36"/>
+                </a:solidFill>
+                <a:latin typeface="Sarabun"/>
+                <a:ea typeface="Sarabun"/>
+                <a:cs typeface="Sarabun"/>
+              </a:rPr>
+              <a:t>แอป: </a:t>
+            </a:r>
+            <a:r>
+              <a:rPr sz="1350" b="1" i="0" u="sng">
+                <a:solidFill>
+                  <a:srgbClr val="7B4FC9"/>
+                </a:solidFill>
+                <a:latin typeface="Sarabun"/>
+                <a:ea typeface="Sarabun"/>
+                <a:cs typeface="Sarabun"/>
+                <a:hlinkClick r:id="rId6"/>
+              </a:rPr>
+              <a:t>claude.ai/download</a:t>
+            </a:r>
+          </a:p>
+          <a:p>
+            <a:pPr algn="l">
+              <a:lnSpc>
+                <a:spcPct val="100000"/>
+              </a:lnSpc>
+              <a:spcAft>
+                <a:spcPts val="300"/>
+              </a:spcAft>
+            </a:pPr>
+            <a:r>
+              <a:rPr sz="1500" b="1" i="0">
+                <a:solidFill>
+                  <a:srgbClr val="4B2A7B"/>
                 </a:solidFill>
                 <a:latin typeface="Prompt"/>
                 <a:ea typeface="Prompt"/>
                 <a:cs typeface="Prompt"/>
               </a:rPr>
-              <a:t>3</a:t>
-            </a:r>
-          </a:p>
-        </p:txBody>
-      </p:sp>
-      <p:sp>
-        <p:nvSpPr>
-          <p:cNvPr id="18" name="TextBox 17"/>
-          <p:cNvSpPr txBox="1"/>
-          <p:nvPr/>
-        </p:nvSpPr>
-        <p:spPr>
-          <a:xfrm>
-            <a:off x="6446520" y="2697480"/>
-            <a:ext cx="2103120" cy="548640"/>
-          </a:xfrm>
-          <a:prstGeom prst="rect">
-            <a:avLst/>
-          </a:prstGeom>
-          <a:noFill/>
-        </p:spPr>
-        <p:txBody>
-          <a:bodyPr wrap="square" anchor="t" lIns="45720" rIns="45720"/>
-          <a:lstStyle/>
-          <a:p>
-            <a:pPr algn="l">
-              <a:lnSpc>
-                <a:spcPct val="110000"/>
-              </a:lnSpc>
-              <a:spcAft>
-                <a:spcPts val="400"/>
-              </a:spcAft>
-            </a:pPr>
-            <a:r>
-              <a:rPr sz="1900" b="1" i="0">
-                <a:solidFill>
-                  <a:srgbClr val="4B2A7B"/>
-                </a:solidFill>
-                <a:latin typeface="Prompt"/>
-                <a:ea typeface="Prompt"/>
-                <a:cs typeface="Prompt"/>
-              </a:rPr>
-              <a:t>มีแพ็กเกจ</a:t>
-            </a:r>
-          </a:p>
-        </p:txBody>
-      </p:sp>
-      <p:sp>
-        <p:nvSpPr>
-          <p:cNvPr id="19" name="TextBox 18"/>
-          <p:cNvSpPr txBox="1"/>
-          <p:nvPr/>
-        </p:nvSpPr>
-        <p:spPr>
-          <a:xfrm>
-            <a:off x="6446520" y="3246120"/>
-            <a:ext cx="2103120" cy="1737360"/>
-          </a:xfrm>
-          <a:prstGeom prst="rect">
-            <a:avLst/>
-          </a:prstGeom>
-          <a:noFill/>
-        </p:spPr>
-        <p:txBody>
-          <a:bodyPr wrap="square" anchor="t" lIns="45720" rIns="45720"/>
-          <a:lstStyle/>
-          <a:p>
-            <a:pPr algn="l">
-              <a:lnSpc>
-                <a:spcPct val="110000"/>
-              </a:lnSpc>
-              <a:spcAft>
-                <a:spcPts val="400"/>
-              </a:spcAft>
-            </a:pPr>
-            <a:r>
-              <a:rPr sz="1500" b="0" i="0">
-                <a:solidFill>
-                  <a:srgbClr val="2E2A36"/>
+              <a:t>Gemini</a:t>
+            </a:r>
+          </a:p>
+          <a:p>
+            <a:pPr algn="l">
+              <a:lnSpc>
+                <a:spcPct val="100000"/>
+              </a:lnSpc>
+              <a:spcAft>
+                <a:spcPts val="300"/>
+              </a:spcAft>
+            </a:pPr>
+            <a:r>
+              <a:rPr sz="1350" b="1" i="0" u="sng">
+                <a:solidFill>
+                  <a:srgbClr val="7B4FC9"/>
                 </a:solidFill>
                 <a:latin typeface="Sarabun"/>
                 <a:ea typeface="Sarabun"/>
                 <a:cs typeface="Sarabun"/>
-              </a:rPr>
-              <a:t>Sign in บัญชี Cursor · Cursor Pro / Pro+ / Ultra / Teams หรือเชื่อม SuperGrok / X Premium+</a:t>
-            </a:r>
-          </a:p>
-        </p:txBody>
-      </p:sp>
-      <p:sp>
-        <p:nvSpPr>
-          <p:cNvPr id="20" name="Rounded Rectangle 19"/>
-          <p:cNvSpPr/>
-          <p:nvPr/>
-        </p:nvSpPr>
-        <p:spPr>
-          <a:xfrm>
-            <a:off x="8915400" y="1600200"/>
-            <a:ext cx="2514600" cy="3429000"/>
-          </a:xfrm>
-          <a:prstGeom prst="roundRect">
-            <a:avLst>
-              <a:gd name="adj" fmla="val 8000"/>
-            </a:avLst>
-          </a:prstGeom>
-          <a:solidFill>
-            <a:srgbClr val="FFFFFF"/>
-          </a:solidFill>
-          <a:ln>
-            <a:noFill/>
-          </a:ln>
-          <a:effectLst/>
-        </p:spPr>
-        <p:style>
-          <a:lnRef idx="1">
-            <a:schemeClr val="accent1"/>
-          </a:lnRef>
-          <a:fillRef idx="3">
-            <a:schemeClr val="accent1"/>
-          </a:fillRef>
-          <a:effectRef idx="2">
-            <a:schemeClr val="accent1"/>
-          </a:effectRef>
-          <a:fontRef idx="minor">
-            <a:schemeClr val="lt1"/>
-          </a:fontRef>
-        </p:style>
-        <p:txBody>
-          <a:bodyPr rtlCol="0" anchor="ctr"/>
-          <a:lstStyle/>
-          <a:p/>
-        </p:txBody>
-      </p:sp>
-      <p:sp>
-        <p:nvSpPr>
-          <p:cNvPr id="21" name="Oval 20"/>
-          <p:cNvSpPr/>
-          <p:nvPr/>
-        </p:nvSpPr>
-        <p:spPr>
-          <a:xfrm>
-            <a:off x="9144000" y="1828800"/>
-            <a:ext cx="685800" cy="685800"/>
-          </a:xfrm>
-          <a:prstGeom prst="ellipse">
-            <a:avLst/>
-          </a:prstGeom>
-          <a:solidFill>
-            <a:srgbClr val="4B2A7B"/>
-          </a:solidFill>
-          <a:ln>
-            <a:noFill/>
-          </a:ln>
-          <a:effectLst/>
-        </p:spPr>
-        <p:style>
-          <a:lnRef idx="1">
-            <a:schemeClr val="accent1"/>
-          </a:lnRef>
-          <a:fillRef idx="3">
-            <a:schemeClr val="accent1"/>
-          </a:fillRef>
-          <a:effectRef idx="2">
-            <a:schemeClr val="accent1"/>
-          </a:effectRef>
-          <a:fontRef idx="minor">
-            <a:schemeClr val="lt1"/>
-          </a:fontRef>
-        </p:style>
-        <p:txBody>
-          <a:bodyPr rtlCol="0" anchor="ctr" wrap="square" lIns="73152" rIns="73152" tIns="73152" bIns="73152"/>
-          <a:lstStyle/>
-          <a:p>
-            <a:pPr algn="ctr"/>
-            <a:r>
-              <a:rPr sz="2200" b="1">
-                <a:solidFill>
-                  <a:srgbClr val="FFFFFF"/>
-                </a:solidFill>
-                <a:latin typeface="Prompt"/>
-                <a:ea typeface="Prompt"/>
-                <a:cs typeface="Prompt"/>
-              </a:rPr>
-              <a:t>4</a:t>
-            </a:r>
-          </a:p>
-        </p:txBody>
-      </p:sp>
-      <p:sp>
-        <p:nvSpPr>
-          <p:cNvPr id="22" name="TextBox 21"/>
-          <p:cNvSpPr txBox="1"/>
-          <p:nvPr/>
-        </p:nvSpPr>
-        <p:spPr>
-          <a:xfrm>
-            <a:off x="9144000" y="2697480"/>
-            <a:ext cx="2103120" cy="548640"/>
-          </a:xfrm>
-          <a:prstGeom prst="rect">
-            <a:avLst/>
-          </a:prstGeom>
-          <a:noFill/>
-        </p:spPr>
-        <p:txBody>
-          <a:bodyPr wrap="square" anchor="t" lIns="45720" rIns="45720"/>
-          <a:lstStyle/>
-          <a:p>
-            <a:pPr algn="l">
-              <a:lnSpc>
-                <a:spcPct val="110000"/>
-              </a:lnSpc>
-              <a:spcAft>
-                <a:spcPts val="400"/>
-              </a:spcAft>
-            </a:pPr>
-            <a:r>
-              <a:rPr sz="1900" b="1" i="0">
-                <a:solidFill>
-                  <a:srgbClr val="4B2A7B"/>
-                </a:solidFill>
-                <a:latin typeface="Prompt"/>
-                <a:ea typeface="Prompt"/>
-                <a:cs typeface="Prompt"/>
-              </a:rPr>
-              <a:t>ไม่มีแพ็กเกจ?</a:t>
-            </a:r>
-          </a:p>
-        </p:txBody>
-      </p:sp>
-      <p:sp>
-        <p:nvSpPr>
-          <p:cNvPr id="23" name="TextBox 22"/>
-          <p:cNvSpPr txBox="1"/>
-          <p:nvPr/>
-        </p:nvSpPr>
-        <p:spPr>
-          <a:xfrm>
-            <a:off x="9144000" y="3246120"/>
-            <a:ext cx="2103120" cy="1737360"/>
-          </a:xfrm>
-          <a:prstGeom prst="rect">
-            <a:avLst/>
-          </a:prstGeom>
-          <a:noFill/>
-        </p:spPr>
-        <p:txBody>
-          <a:bodyPr wrap="square" anchor="t" lIns="45720" rIns="45720"/>
-          <a:lstStyle/>
-          <a:p>
-            <a:pPr algn="l">
-              <a:lnSpc>
-                <a:spcPct val="110000"/>
-              </a:lnSpc>
-              <a:spcAft>
-                <a:spcPts val="400"/>
-              </a:spcAft>
-            </a:pPr>
-            <a:r>
-              <a:rPr sz="1500" b="0" i="0">
-                <a:solidFill>
-                  <a:srgbClr val="2E2A36"/>
+                <a:hlinkClick r:id="rId7"/>
+              </a:rPr>
+              <a:t>gemini.google.com</a:t>
+            </a:r>
+          </a:p>
+          <a:p>
+            <a:pPr algn="l">
+              <a:lnSpc>
+                <a:spcPct val="100000"/>
+              </a:lnSpc>
+              <a:spcAft>
+                <a:spcPts val="300"/>
+              </a:spcAft>
+            </a:pPr>
+            <a:r>
+              <a:rPr sz="1250" b="0" i="0">
+                <a:solidFill>
+                  <a:srgbClr val="5F596B"/>
                 </a:solidFill>
                 <a:latin typeface="Sarabun"/>
                 <a:ea typeface="Sarabun"/>
                 <a:cs typeface="Sarabun"/>
               </a:rPr>
-              <a:t>ล็อกอิน ChatGPT (ฟรี) ไว้ แล้วทำตามแผนสำรอง ChatGPT Projects</a:t>
-            </a:r>
-          </a:p>
-        </p:txBody>
-      </p:sp>
-      <p:sp>
-        <p:nvSpPr>
-          <p:cNvPr id="24" name="Rounded Rectangle 23"/>
+              <a:t>มือถือ: แอป Gemini (iOS / Android)</a:t>
+            </a:r>
+          </a:p>
+        </p:txBody>
+      </p:sp>
+      <p:sp>
+        <p:nvSpPr>
+          <p:cNvPr id="28" name="Rounded Rectangle 27"/>
           <p:cNvSpPr/>
           <p:nvPr/>
         </p:nvSpPr>
         <p:spPr>
           <a:xfrm>
-            <a:off x="822960" y="5257800"/>
+            <a:off x="822960" y="5285232"/>
             <a:ext cx="10515600" cy="868680"/>
           </a:xfrm>
           <a:prstGeom prst="roundRect">
@@ -25471,7 +25987,7 @@
                 <a:ea typeface="Sarabun"/>
                 <a:cs typeface="Sarabun"/>
               </a:rPr>
-              <a:t>ติดตั้ง → Sign in → ผ่านขั้นตอนแนะนำครั้งแรก (ระบบตั้งค่าคอมพิวเตอร์บนคลาวด์ให้ ใช้เวลาสักพัก)</a:t>
+              <a:t>ติดตั้ง → Sign in → ทำขั้นตอนแนะนำครั้งแรกของ Grok Bot ให้จบ (ใช้เวลาสักพัก)</a:t>
             </a:r>
           </a:p>
           <a:p>
@@ -30700,10 +31216,10 @@
         <a:srgbClr val="F79646"/>
       </a:accent6>
       <a:hlink>
-        <a:srgbClr val="0000FF"/>
+        <a:srgbClr val="7B4FC9"/>
       </a:hlink>
       <a:folHlink>
-        <a:srgbClr val="800080"/>
+        <a:srgbClr val="7B4FC9"/>
       </a:folHlink>
     </a:clrScheme>
     <a:fontScheme name="Office">

</xml_diff>

<commit_message>
Add AI คืออะไร to slide 5 and cheat sheet
</commit_message>
<xml_diff>
--- a/AI_Workshop.pptx
+++ b/AI_Workshop.pptx
@@ -2575,7 +2575,12 @@
           </a:p>
           <a:p>
             <a:r>
-              <a:t>- LLM ย่อมาจาก Large Language Model — เหมือนคนที่อ่านหนังสือทั้งห้องสมุด จนรู้ว่าประโยคแบบนี้ควรต่อด้วยอะไร</a:t>
+              <a:t>- AI ย่อมาจาก Artificial Intelligence หรือ “ปัญญาประดิษฐ์” คือโปรแกรมคอมพิวเตอร์ที่เรียนรู้จากข้อมูลจำนวนมหาศาล เพื่อทำงานที่ปกติต้องใช้ความคิดแบบคน เช่น เข้าใจภาษา ตอบคำถาม เขียน สรุปเอกสาร จดจำภาพ และช่วยวางแผน</a:t>
+            </a:r>
+          </a:p>
+          <a:p>
+            <a:r>
+              <a:t>- ChatGPT, Claude, Gemini และ Grok Bot ที่เราจะใช้วันนี้ เป็น AI กลุ่ม Large Language Model (LLM) หรือ “โมเดลภาษา” — ฝึกจากข้อความมหาศาล เหมือนคนที่อ่านหนังสือทั้งห้องสมุด จนเดาได้ว่าคำตอบแบบไหนเหมาะกับคำถามนี้</a:t>
             </a:r>
           </a:p>
           <a:p>
@@ -2585,7 +2590,7 @@
           </a:p>
           <a:p>
             <a:r>
-              <a:t>- ข้อควรรู้: AI ตอบผิดได้แบบมั่นใจมาก (เรียกว่า hallucination) โดยเฉพาะตัวเลข ชื่อ วันที่ เรื่องสุขภาพ การเงิน กฎหมาย ต้องตรวจซ้ำ</a:t>
+              <a:t>- ข้อควรรู้: มันไม่ได้ “รู้” หรือ “เข้าใจ” จริงแบบคน — ตอบผิดได้แบบมั่นใจมาก (เรียกว่า hallucination) โดยเฉพาะตัวเลข ชื่อ วันที่ เรื่องสุขภาพ การเงิน กฎหมาย ต้องตรวจซ้ำทุกครั้ง</a:t>
             </a:r>
           </a:p>
           <a:p>
@@ -2595,7 +2600,7 @@
           </a:p>
           <a:p>
             <a:r>
-              <a:t>ถามผู้ฟัง: เคยเจอ AI ตอบมั่วไหมคะ? (รับ 1 เรื่องสั้นๆ)</a:t>
+              <a:t>ถามผู้ฟัง: เคยเจอ AI ตอบมั่วไหมคะ? (รับ 1 เรื่องสั้นๆ — ถ้าเวลาไม่พอ ข้ามได้ เพื่อให้ยังอยู่ใน 4 นาที)</a:t>
             </a:r>
           </a:p>
         </p:txBody>
@@ -26153,7 +26158,7 @@
                 <a:ea typeface="Prompt"/>
                 <a:cs typeface="Prompt"/>
               </a:rPr>
-              <a:t>AI / LLM คืออะไร — แบบภาษาคน</a:t>
+              <a:t>AI คืออะไร — แบบภาษาคน</a:t>
             </a:r>
           </a:p>
         </p:txBody>
@@ -26307,12 +26312,109 @@
         </p:nvSpPr>
         <p:spPr>
           <a:xfrm>
-            <a:off x="822960" y="1645920"/>
-            <a:ext cx="3383280" cy="2743200"/>
+            <a:off x="822960" y="1508760"/>
+            <a:ext cx="10515600" cy="1417320"/>
           </a:xfrm>
           <a:prstGeom prst="roundRect">
             <a:avLst>
-              <a:gd name="adj" fmla="val 6000"/>
+              <a:gd name="adj" fmla="val 12000"/>
+            </a:avLst>
+          </a:prstGeom>
+          <a:solidFill>
+            <a:srgbClr val="E7DEF8"/>
+          </a:solidFill>
+          <a:ln>
+            <a:noFill/>
+          </a:ln>
+          <a:effectLst/>
+        </p:spPr>
+        <p:style>
+          <a:lnRef idx="1">
+            <a:schemeClr val="accent1"/>
+          </a:lnRef>
+          <a:fillRef idx="3">
+            <a:schemeClr val="accent1"/>
+          </a:fillRef>
+          <a:effectRef idx="2">
+            <a:schemeClr val="accent1"/>
+          </a:effectRef>
+          <a:fontRef idx="minor">
+            <a:schemeClr val="lt1"/>
+          </a:fontRef>
+        </p:style>
+        <p:txBody>
+          <a:bodyPr rtlCol="0" anchor="ctr"/>
+          <a:lstStyle/>
+          <a:p/>
+        </p:txBody>
+      </p:sp>
+      <p:sp>
+        <p:nvSpPr>
+          <p:cNvPr id="9" name="TextBox 8"/>
+          <p:cNvSpPr txBox="1"/>
+          <p:nvPr/>
+        </p:nvSpPr>
+        <p:spPr>
+          <a:xfrm>
+            <a:off x="1097280" y="1591056"/>
+            <a:ext cx="10058400" cy="777240"/>
+          </a:xfrm>
+          <a:prstGeom prst="rect">
+            <a:avLst/>
+          </a:prstGeom>
+          <a:noFill/>
+        </p:spPr>
+        <p:txBody>
+          <a:bodyPr wrap="square" anchor="t" lIns="45720" rIns="45720"/>
+          <a:lstStyle/>
+          <a:p>
+            <a:pPr algn="l">
+              <a:lnSpc>
+                <a:spcPct val="105000"/>
+              </a:lnSpc>
+              <a:spcAft>
+                <a:spcPts val="400"/>
+              </a:spcAft>
+            </a:pPr>
+            <a:r>
+              <a:rPr sz="1900" b="1" i="0">
+                <a:solidFill>
+                  <a:srgbClr val="4B2A7B"/>
+                </a:solidFill>
+                <a:latin typeface="Prompt"/>
+                <a:ea typeface="Prompt"/>
+                <a:cs typeface="Prompt"/>
+              </a:rPr>
+              <a:t>AI (Artificial Intelligence / ปัญญาประดิษฐ์) </a:t>
+            </a:r>
+            <a:r>
+              <a:rPr sz="1700" b="0" i="0">
+                <a:solidFill>
+                  <a:srgbClr val="2E2A36"/>
+                </a:solidFill>
+                <a:latin typeface="Sarabun"/>
+                <a:ea typeface="Sarabun"/>
+                <a:cs typeface="Sarabun"/>
+              </a:rPr>
+              <a:t>= โปรแกรมคอมพิวเตอร์ที่เรียนรู้จากข้อมูลจำนวนมหาศาล เพื่อทำงานที่ปกติต้องใช้ความคิดแบบมนุษย์</a:t>
+            </a:r>
+          </a:p>
+        </p:txBody>
+      </p:sp>
+      <p:sp>
+        <p:nvSpPr>
+          <p:cNvPr id="10" name="Rounded Rectangle 9"/>
+          <p:cNvSpPr/>
+          <p:nvPr/>
+        </p:nvSpPr>
+        <p:spPr>
+          <a:xfrm>
+            <a:off x="1097280" y="2432304"/>
+            <a:ext cx="1435608" cy="347472"/>
+          </a:xfrm>
+          <a:prstGeom prst="roundRect">
+            <a:avLst>
+              <a:gd name="adj" fmla="val 50000"/>
             </a:avLst>
           </a:prstGeom>
           <a:solidFill>
@@ -26338,6 +26440,348 @@
           </a:fontRef>
         </p:style>
         <p:txBody>
+          <a:bodyPr rtlCol="0" anchor="ctr" wrap="square" lIns="18288" rIns="18288" tIns="18288" bIns="18288"/>
+          <a:lstStyle/>
+          <a:p>
+            <a:pPr algn="ctr"/>
+            <a:r>
+              <a:rPr sz="1300" b="1">
+                <a:solidFill>
+                  <a:srgbClr val="4B2A7B"/>
+                </a:solidFill>
+                <a:latin typeface="Prompt"/>
+                <a:ea typeface="Prompt"/>
+                <a:cs typeface="Prompt"/>
+              </a:rPr>
+              <a:t>เข้าใจภาษา</a:t>
+            </a:r>
+          </a:p>
+        </p:txBody>
+      </p:sp>
+      <p:sp>
+        <p:nvSpPr>
+          <p:cNvPr id="11" name="Rounded Rectangle 10"/>
+          <p:cNvSpPr/>
+          <p:nvPr/>
+        </p:nvSpPr>
+        <p:spPr>
+          <a:xfrm>
+            <a:off x="2670048" y="2432304"/>
+            <a:ext cx="1225296" cy="347472"/>
+          </a:xfrm>
+          <a:prstGeom prst="roundRect">
+            <a:avLst>
+              <a:gd name="adj" fmla="val 50000"/>
+            </a:avLst>
+          </a:prstGeom>
+          <a:solidFill>
+            <a:srgbClr val="FFFFFF"/>
+          </a:solidFill>
+          <a:ln>
+            <a:noFill/>
+          </a:ln>
+          <a:effectLst/>
+        </p:spPr>
+        <p:style>
+          <a:lnRef idx="1">
+            <a:schemeClr val="accent1"/>
+          </a:lnRef>
+          <a:fillRef idx="3">
+            <a:schemeClr val="accent1"/>
+          </a:fillRef>
+          <a:effectRef idx="2">
+            <a:schemeClr val="accent1"/>
+          </a:effectRef>
+          <a:fontRef idx="minor">
+            <a:schemeClr val="lt1"/>
+          </a:fontRef>
+        </p:style>
+        <p:txBody>
+          <a:bodyPr rtlCol="0" anchor="ctr" wrap="square" lIns="18288" rIns="18288" tIns="18288" bIns="18288"/>
+          <a:lstStyle/>
+          <a:p>
+            <a:pPr algn="ctr"/>
+            <a:r>
+              <a:rPr sz="1300" b="1">
+                <a:solidFill>
+                  <a:srgbClr val="4B2A7B"/>
+                </a:solidFill>
+                <a:latin typeface="Prompt"/>
+                <a:ea typeface="Prompt"/>
+                <a:cs typeface="Prompt"/>
+              </a:rPr>
+              <a:t>ตอบคำถาม</a:t>
+            </a:r>
+          </a:p>
+        </p:txBody>
+      </p:sp>
+      <p:sp>
+        <p:nvSpPr>
+          <p:cNvPr id="12" name="Rounded Rectangle 11"/>
+          <p:cNvSpPr/>
+          <p:nvPr/>
+        </p:nvSpPr>
+        <p:spPr>
+          <a:xfrm>
+            <a:off x="4032504" y="2432304"/>
+            <a:ext cx="909828" cy="347472"/>
+          </a:xfrm>
+          <a:prstGeom prst="roundRect">
+            <a:avLst>
+              <a:gd name="adj" fmla="val 50000"/>
+            </a:avLst>
+          </a:prstGeom>
+          <a:solidFill>
+            <a:srgbClr val="FFFFFF"/>
+          </a:solidFill>
+          <a:ln>
+            <a:noFill/>
+          </a:ln>
+          <a:effectLst/>
+        </p:spPr>
+        <p:style>
+          <a:lnRef idx="1">
+            <a:schemeClr val="accent1"/>
+          </a:lnRef>
+          <a:fillRef idx="3">
+            <a:schemeClr val="accent1"/>
+          </a:fillRef>
+          <a:effectRef idx="2">
+            <a:schemeClr val="accent1"/>
+          </a:effectRef>
+          <a:fontRef idx="minor">
+            <a:schemeClr val="lt1"/>
+          </a:fontRef>
+        </p:style>
+        <p:txBody>
+          <a:bodyPr rtlCol="0" anchor="ctr" wrap="square" lIns="18288" rIns="18288" tIns="18288" bIns="18288"/>
+          <a:lstStyle/>
+          <a:p>
+            <a:pPr algn="ctr"/>
+            <a:r>
+              <a:rPr sz="1300" b="1">
+                <a:solidFill>
+                  <a:srgbClr val="4B2A7B"/>
+                </a:solidFill>
+                <a:latin typeface="Prompt"/>
+                <a:ea typeface="Prompt"/>
+                <a:cs typeface="Prompt"/>
+              </a:rPr>
+              <a:t>เขียน</a:t>
+            </a:r>
+          </a:p>
+        </p:txBody>
+      </p:sp>
+      <p:sp>
+        <p:nvSpPr>
+          <p:cNvPr id="13" name="Rounded Rectangle 12"/>
+          <p:cNvSpPr/>
+          <p:nvPr/>
+        </p:nvSpPr>
+        <p:spPr>
+          <a:xfrm>
+            <a:off x="5079492" y="2432304"/>
+            <a:ext cx="1435608" cy="347472"/>
+          </a:xfrm>
+          <a:prstGeom prst="roundRect">
+            <a:avLst>
+              <a:gd name="adj" fmla="val 50000"/>
+            </a:avLst>
+          </a:prstGeom>
+          <a:solidFill>
+            <a:srgbClr val="FFFFFF"/>
+          </a:solidFill>
+          <a:ln>
+            <a:noFill/>
+          </a:ln>
+          <a:effectLst/>
+        </p:spPr>
+        <p:style>
+          <a:lnRef idx="1">
+            <a:schemeClr val="accent1"/>
+          </a:lnRef>
+          <a:fillRef idx="3">
+            <a:schemeClr val="accent1"/>
+          </a:fillRef>
+          <a:effectRef idx="2">
+            <a:schemeClr val="accent1"/>
+          </a:effectRef>
+          <a:fontRef idx="minor">
+            <a:schemeClr val="lt1"/>
+          </a:fontRef>
+        </p:style>
+        <p:txBody>
+          <a:bodyPr rtlCol="0" anchor="ctr" wrap="square" lIns="18288" rIns="18288" tIns="18288" bIns="18288"/>
+          <a:lstStyle/>
+          <a:p>
+            <a:pPr algn="ctr"/>
+            <a:r>
+              <a:rPr sz="1300" b="1">
+                <a:solidFill>
+                  <a:srgbClr val="4B2A7B"/>
+                </a:solidFill>
+                <a:latin typeface="Prompt"/>
+                <a:ea typeface="Prompt"/>
+                <a:cs typeface="Prompt"/>
+              </a:rPr>
+              <a:t>สรุปเอกสาร</a:t>
+            </a:r>
+          </a:p>
+        </p:txBody>
+      </p:sp>
+      <p:sp>
+        <p:nvSpPr>
+          <p:cNvPr id="14" name="Rounded Rectangle 13"/>
+          <p:cNvSpPr/>
+          <p:nvPr/>
+        </p:nvSpPr>
+        <p:spPr>
+          <a:xfrm>
+            <a:off x="6652259" y="2432304"/>
+            <a:ext cx="1120140" cy="347472"/>
+          </a:xfrm>
+          <a:prstGeom prst="roundRect">
+            <a:avLst>
+              <a:gd name="adj" fmla="val 50000"/>
+            </a:avLst>
+          </a:prstGeom>
+          <a:solidFill>
+            <a:srgbClr val="FFFFFF"/>
+          </a:solidFill>
+          <a:ln>
+            <a:noFill/>
+          </a:ln>
+          <a:effectLst/>
+        </p:spPr>
+        <p:style>
+          <a:lnRef idx="1">
+            <a:schemeClr val="accent1"/>
+          </a:lnRef>
+          <a:fillRef idx="3">
+            <a:schemeClr val="accent1"/>
+          </a:fillRef>
+          <a:effectRef idx="2">
+            <a:schemeClr val="accent1"/>
+          </a:effectRef>
+          <a:fontRef idx="minor">
+            <a:schemeClr val="lt1"/>
+          </a:fontRef>
+        </p:style>
+        <p:txBody>
+          <a:bodyPr rtlCol="0" anchor="ctr" wrap="square" lIns="18288" rIns="18288" tIns="18288" bIns="18288"/>
+          <a:lstStyle/>
+          <a:p>
+            <a:pPr algn="ctr"/>
+            <a:r>
+              <a:rPr sz="1300" b="1">
+                <a:solidFill>
+                  <a:srgbClr val="4B2A7B"/>
+                </a:solidFill>
+                <a:latin typeface="Prompt"/>
+                <a:ea typeface="Prompt"/>
+                <a:cs typeface="Prompt"/>
+              </a:rPr>
+              <a:t>จดจำภาพ</a:t>
+            </a:r>
+          </a:p>
+        </p:txBody>
+      </p:sp>
+      <p:sp>
+        <p:nvSpPr>
+          <p:cNvPr id="15" name="Rounded Rectangle 14"/>
+          <p:cNvSpPr/>
+          <p:nvPr/>
+        </p:nvSpPr>
+        <p:spPr>
+          <a:xfrm>
+            <a:off x="7909559" y="2432304"/>
+            <a:ext cx="1435608" cy="347472"/>
+          </a:xfrm>
+          <a:prstGeom prst="roundRect">
+            <a:avLst>
+              <a:gd name="adj" fmla="val 50000"/>
+            </a:avLst>
+          </a:prstGeom>
+          <a:solidFill>
+            <a:srgbClr val="FFFFFF"/>
+          </a:solidFill>
+          <a:ln>
+            <a:noFill/>
+          </a:ln>
+          <a:effectLst/>
+        </p:spPr>
+        <p:style>
+          <a:lnRef idx="1">
+            <a:schemeClr val="accent1"/>
+          </a:lnRef>
+          <a:fillRef idx="3">
+            <a:schemeClr val="accent1"/>
+          </a:fillRef>
+          <a:effectRef idx="2">
+            <a:schemeClr val="accent1"/>
+          </a:effectRef>
+          <a:fontRef idx="minor">
+            <a:schemeClr val="lt1"/>
+          </a:fontRef>
+        </p:style>
+        <p:txBody>
+          <a:bodyPr rtlCol="0" anchor="ctr" wrap="square" lIns="18288" rIns="18288" tIns="18288" bIns="18288"/>
+          <a:lstStyle/>
+          <a:p>
+            <a:pPr algn="ctr"/>
+            <a:r>
+              <a:rPr sz="1300" b="1">
+                <a:solidFill>
+                  <a:srgbClr val="4B2A7B"/>
+                </a:solidFill>
+                <a:latin typeface="Prompt"/>
+                <a:ea typeface="Prompt"/>
+                <a:cs typeface="Prompt"/>
+              </a:rPr>
+              <a:t>ช่วยวางแผน</a:t>
+            </a:r>
+          </a:p>
+        </p:txBody>
+      </p:sp>
+      <p:sp>
+        <p:nvSpPr>
+          <p:cNvPr id="16" name="Rounded Rectangle 15"/>
+          <p:cNvSpPr/>
+          <p:nvPr/>
+        </p:nvSpPr>
+        <p:spPr>
+          <a:xfrm>
+            <a:off x="822960" y="3090672"/>
+            <a:ext cx="3383280" cy="1801368"/>
+          </a:xfrm>
+          <a:prstGeom prst="roundRect">
+            <a:avLst>
+              <a:gd name="adj" fmla="val 6000"/>
+            </a:avLst>
+          </a:prstGeom>
+          <a:solidFill>
+            <a:srgbClr val="FFFFFF"/>
+          </a:solidFill>
+          <a:ln>
+            <a:noFill/>
+          </a:ln>
+          <a:effectLst/>
+        </p:spPr>
+        <p:style>
+          <a:lnRef idx="1">
+            <a:schemeClr val="accent1"/>
+          </a:lnRef>
+          <a:fillRef idx="3">
+            <a:schemeClr val="accent1"/>
+          </a:fillRef>
+          <a:effectRef idx="2">
+            <a:schemeClr val="accent1"/>
+          </a:effectRef>
+          <a:fontRef idx="minor">
+            <a:schemeClr val="lt1"/>
+          </a:fontRef>
+        </p:style>
+        <p:txBody>
           <a:bodyPr rtlCol="0" anchor="ctr"/>
           <a:lstStyle/>
           <a:p/>
@@ -26345,13 +26789,13 @@
       </p:sp>
       <p:sp>
         <p:nvSpPr>
-          <p:cNvPr id="9" name="Rectangle 8"/>
+          <p:cNvPr id="17" name="Rectangle 16"/>
           <p:cNvSpPr/>
           <p:nvPr/>
         </p:nvSpPr>
         <p:spPr>
           <a:xfrm>
-            <a:off x="1051560" y="1847088"/>
+            <a:off x="1051560" y="3291840"/>
             <a:ext cx="457200" cy="64008"/>
           </a:xfrm>
           <a:prstGeom prst="rect">
@@ -26387,13 +26831,13 @@
       </p:sp>
       <p:sp>
         <p:nvSpPr>
-          <p:cNvPr id="10" name="TextBox 9"/>
+          <p:cNvPr id="18" name="TextBox 17"/>
           <p:cNvSpPr txBox="1"/>
           <p:nvPr/>
         </p:nvSpPr>
         <p:spPr>
           <a:xfrm>
-            <a:off x="1005840" y="1965960"/>
+            <a:off x="1005840" y="3410712"/>
             <a:ext cx="3017520" cy="502920"/>
           </a:xfrm>
           <a:prstGeom prst="rect">
@@ -26422,21 +26866,21 @@
                 <a:ea typeface="Prompt"/>
                 <a:cs typeface="Prompt"/>
               </a:rPr>
-              <a:t>LLM = นักอ่านตัวยง</a:t>
-            </a:r>
-          </a:p>
-        </p:txBody>
-      </p:sp>
-      <p:sp>
-        <p:nvSpPr>
-          <p:cNvPr id="11" name="TextBox 10"/>
+              <a:t>LLM = โมเดลภาษา</a:t>
+            </a:r>
+          </a:p>
+        </p:txBody>
+      </p:sp>
+      <p:sp>
+        <p:nvSpPr>
+          <p:cNvPr id="19" name="TextBox 18"/>
           <p:cNvSpPr txBox="1"/>
           <p:nvPr/>
         </p:nvSpPr>
         <p:spPr>
           <a:xfrm>
-            <a:off x="1005840" y="2423160"/>
-            <a:ext cx="3017520" cy="1874520"/>
+            <a:off x="1005840" y="3867912"/>
+            <a:ext cx="3017520" cy="932687"/>
           </a:xfrm>
           <a:prstGeom prst="rect">
             <a:avLst/>
@@ -26464,21 +26908,21 @@
                 <a:ea typeface="Sarabun"/>
                 <a:cs typeface="Sarabun"/>
               </a:rPr>
-              <a:t>Large Language Model คือโปรแกรมที่ “อ่าน” ข้อความมหาศาล จนเรียนรู้รูปแบบภาษา แล้วเดาคำถัดไปได้อย่างแม่นยำ</a:t>
-            </a:r>
-          </a:p>
-        </p:txBody>
-      </p:sp>
-      <p:sp>
-        <p:nvSpPr>
-          <p:cNvPr id="12" name="Rounded Rectangle 11"/>
+              <a:t>ChatGPT · Claude · Gemini · Grok Bot ฝึกจากข้อความมหาศาล เพื่อเดา “คำตอบที่เหมาะสม” ทีละคำ</a:t>
+            </a:r>
+          </a:p>
+        </p:txBody>
+      </p:sp>
+      <p:sp>
+        <p:nvSpPr>
+          <p:cNvPr id="20" name="Rounded Rectangle 19"/>
           <p:cNvSpPr/>
           <p:nvPr/>
         </p:nvSpPr>
         <p:spPr>
           <a:xfrm>
-            <a:off x="4389120" y="1645920"/>
-            <a:ext cx="3383280" cy="2743200"/>
+            <a:off x="4389120" y="3090672"/>
+            <a:ext cx="3383280" cy="1801368"/>
           </a:xfrm>
           <a:prstGeom prst="roundRect">
             <a:avLst>
@@ -26515,13 +26959,13 @@
       </p:sp>
       <p:sp>
         <p:nvSpPr>
-          <p:cNvPr id="13" name="Rectangle 12"/>
+          <p:cNvPr id="21" name="Rectangle 20"/>
           <p:cNvSpPr/>
           <p:nvPr/>
         </p:nvSpPr>
         <p:spPr>
           <a:xfrm>
-            <a:off x="4617720" y="1847088"/>
+            <a:off x="4617720" y="3291840"/>
             <a:ext cx="457200" cy="64008"/>
           </a:xfrm>
           <a:prstGeom prst="rect">
@@ -26557,13 +27001,13 @@
       </p:sp>
       <p:sp>
         <p:nvSpPr>
-          <p:cNvPr id="14" name="TextBox 13"/>
+          <p:cNvPr id="22" name="TextBox 21"/>
           <p:cNvSpPr txBox="1"/>
           <p:nvPr/>
         </p:nvSpPr>
         <p:spPr>
           <a:xfrm>
-            <a:off x="4572000" y="1965960"/>
+            <a:off x="4572000" y="3410712"/>
             <a:ext cx="3017520" cy="502920"/>
           </a:xfrm>
           <a:prstGeom prst="rect">
@@ -26599,14 +27043,14 @@
       </p:sp>
       <p:sp>
         <p:nvSpPr>
-          <p:cNvPr id="15" name="TextBox 14"/>
+          <p:cNvPr id="23" name="TextBox 22"/>
           <p:cNvSpPr txBox="1"/>
           <p:nvPr/>
         </p:nvSpPr>
         <p:spPr>
           <a:xfrm>
-            <a:off x="4572000" y="2423160"/>
-            <a:ext cx="3017520" cy="1874520"/>
+            <a:off x="4572000" y="3867912"/>
+            <a:ext cx="3017520" cy="932687"/>
           </a:xfrm>
           <a:prstGeom prst="rect">
             <a:avLst/>
@@ -26634,21 +27078,21 @@
                 <a:ea typeface="Sarabun"/>
                 <a:cs typeface="Sarabun"/>
               </a:rPr>
-              <a:t>เราสั่งงานด้วยภาษาธรรมดา (ไทยก็ได้) → มันเขียน สรุป แปล วางแผน ตอบคำถาม หรือช่วยคิดให้</a:t>
-            </a:r>
-          </a:p>
-        </p:txBody>
-      </p:sp>
-      <p:sp>
-        <p:nvSpPr>
-          <p:cNvPr id="16" name="Rounded Rectangle 15"/>
+              <a:t>สั่งงานด้วยภาษาธรรมดา (ไทยก็ได้) → เขียน สรุป แปล วางแผน ตอบคำถาม หรือช่วยคิดให้</a:t>
+            </a:r>
+          </a:p>
+        </p:txBody>
+      </p:sp>
+      <p:sp>
+        <p:nvSpPr>
+          <p:cNvPr id="24" name="Rounded Rectangle 23"/>
           <p:cNvSpPr/>
           <p:nvPr/>
         </p:nvSpPr>
         <p:spPr>
           <a:xfrm>
-            <a:off x="7955279" y="1645920"/>
-            <a:ext cx="3383280" cy="2743200"/>
+            <a:off x="7955279" y="3090672"/>
+            <a:ext cx="3383280" cy="1801368"/>
           </a:xfrm>
           <a:prstGeom prst="roundRect">
             <a:avLst>
@@ -26685,13 +27129,13 @@
       </p:sp>
       <p:sp>
         <p:nvSpPr>
-          <p:cNvPr id="17" name="Rectangle 16"/>
+          <p:cNvPr id="25" name="Rectangle 24"/>
           <p:cNvSpPr/>
           <p:nvPr/>
         </p:nvSpPr>
         <p:spPr>
           <a:xfrm>
-            <a:off x="8183879" y="1847088"/>
+            <a:off x="8183879" y="3291840"/>
             <a:ext cx="457200" cy="64008"/>
           </a:xfrm>
           <a:prstGeom prst="rect">
@@ -26727,13 +27171,13 @@
       </p:sp>
       <p:sp>
         <p:nvSpPr>
-          <p:cNvPr id="18" name="TextBox 17"/>
+          <p:cNvPr id="26" name="TextBox 25"/>
           <p:cNvSpPr txBox="1"/>
           <p:nvPr/>
         </p:nvSpPr>
         <p:spPr>
           <a:xfrm>
-            <a:off x="8138159" y="1965960"/>
+            <a:off x="8138159" y="3410712"/>
             <a:ext cx="3017520" cy="502920"/>
           </a:xfrm>
           <a:prstGeom prst="rect">
@@ -26762,21 +27206,21 @@
                 <a:ea typeface="Prompt"/>
                 <a:cs typeface="Prompt"/>
               </a:rPr>
-              <a:t>แต่ไม่ใช่ผู้รู้ทุกอย่าง</a:t>
-            </a:r>
-          </a:p>
-        </p:txBody>
-      </p:sp>
-      <p:sp>
-        <p:nvSpPr>
-          <p:cNvPr id="19" name="TextBox 18"/>
+              <a:t>แต่ไม่ได้ “รู้” แบบคน</a:t>
+            </a:r>
+          </a:p>
+        </p:txBody>
+      </p:sp>
+      <p:sp>
+        <p:nvSpPr>
+          <p:cNvPr id="27" name="TextBox 26"/>
           <p:cNvSpPr txBox="1"/>
           <p:nvPr/>
         </p:nvSpPr>
         <p:spPr>
           <a:xfrm>
-            <a:off x="8138159" y="2423160"/>
-            <a:ext cx="3017520" cy="1874520"/>
+            <a:off x="8138159" y="3867912"/>
+            <a:ext cx="3017520" cy="932687"/>
           </a:xfrm>
           <a:prstGeom prst="rect">
             <a:avLst/>
@@ -26804,21 +27248,21 @@
                 <a:ea typeface="Sarabun"/>
                 <a:cs typeface="Sarabun"/>
               </a:rPr>
-              <a:t>บางครั้ง “มั่นใจแต่ผิด” (hallucination) · ข้อมูลอาจไม่อัปเดต ถ้าไม่ได้ค้นเว็บ · ต้องตรวจเรื่องสำคัญเสมอ</a:t>
-            </a:r>
-          </a:p>
-        </p:txBody>
-      </p:sp>
-      <p:sp>
-        <p:nvSpPr>
-          <p:cNvPr id="20" name="Rounded Rectangle 19"/>
+              <a:t>ไม่ได้เข้าใจจริงแบบมนุษย์ · ตอบผิดได้แบบมั่นใจ (hallucination) · เรื่องสำคัญต้องตรวจสอบเสมอ</a:t>
+            </a:r>
+          </a:p>
+        </p:txBody>
+      </p:sp>
+      <p:sp>
+        <p:nvSpPr>
+          <p:cNvPr id="28" name="Rounded Rectangle 27"/>
           <p:cNvSpPr/>
           <p:nvPr/>
         </p:nvSpPr>
         <p:spPr>
           <a:xfrm>
-            <a:off x="822960" y="4663440"/>
-            <a:ext cx="10515600" cy="1325880"/>
+            <a:off x="822960" y="5074920"/>
+            <a:ext cx="10515600" cy="1051560"/>
           </a:xfrm>
           <a:prstGeom prst="roundRect">
             <a:avLst>
@@ -26848,12 +27292,12 @@
           </a:fontRef>
         </p:style>
         <p:txBody>
-          <a:bodyPr rtlCol="0" anchor="ctr" wrap="square" lIns="320040" rIns="320040" tIns="320040" bIns="320040"/>
+          <a:bodyPr rtlCol="0" anchor="ctr" wrap="square" lIns="274320" rIns="274320" tIns="274320" bIns="274320"/>
           <a:lstStyle/>
           <a:p>
             <a:pPr algn="l"/>
             <a:r>
-              <a:rPr sz="2000" b="1">
+              <a:rPr sz="1900" b="1">
                 <a:solidFill>
                   <a:srgbClr val="C9B6EE"/>
                 </a:solidFill>
@@ -26864,7 +27308,7 @@
               <a:t>เปรียบง่ายๆ: </a:t>
             </a:r>
             <a:r>
-              <a:rPr sz="2000" b="0">
+              <a:rPr sz="1900" b="0">
                 <a:solidFill>
                   <a:srgbClr val="FFFFFF"/>
                 </a:solidFill>
@@ -26878,7 +27322,7 @@
           <a:p>
             <a:pPr algn="l"/>
             <a:r>
-              <a:rPr sz="1600" b="0">
+              <a:rPr sz="1500" b="0">
                 <a:solidFill>
                   <a:srgbClr val="E7DEF8"/>
                 </a:solidFill>

</xml_diff>